<commit_message>
fix: reduce list_basic title to 48pt; add true 3-column layout for three_cards
- _style_content_layout: size_pt 64→48, gap between title/content increased
  Prevents 13-char JP titles from wrapping into the content area
- _style_two_content_layout: inject 3rd OBJECT placeholder (idx=3) via
  _add_object_placeholder(), reposition all three columns to equal thirds
  (col_w≈3.878", 0.3" gap, 0.55" margins)
- Add 3 rounded-rect card backgrounds matching the three columns
- Add _add_object_placeholder() helper: creates OBJECT placeholder in layout
  spTree via direct lxml XML insertion without cloning, maintaining python-pptx
  compatibility
- Regenerated templates/default.pptx and default.manifest.json

cards[0..2] now each bind to dedicated placeholder idx=1,2,3 (was 1,2,2)

Co-authored-by: Copilot <223556219+Copilot@users.noreply.github.com>
</commit_message>
<xml_diff>
--- a/templates/default.pptx
+++ b/templates/default.pptx
@@ -4,7 +4,7 @@
   <p:sldMasterIdLst>
     <p:sldMasterId id="2147483648" r:id="rId1"/>
   </p:sldMasterIdLst>
-  <p:sldSz cx="12192000" cy="6858000" type="screen4x3"/>
+  <p:sldSz cx="12191999" cy="6858000" type="screen4x3"/>
   <p:notesSz cx="6858000" cy="9144000"/>
   <p:defaultTextStyle>
     <a:defPPr>
@@ -110,7 +110,7 @@
     <p:bg>
       <p:bgPr>
         <a:solidFill>
-          <a:srgbClr val="1A3A6C"/>
+          <a:srgbClr val="FFFFFF"/>
         </a:solidFill>
         <a:effectLst/>
       </p:bgPr>
@@ -141,22 +141,27 @@
         </p:nvSpPr>
         <p:spPr>
           <a:xfrm>
-            <a:off x="685800" y="2130425"/>
-            <a:ext cx="7772400" cy="1470025"/>
+            <a:off x="502920" y="1645920"/>
+            <a:ext cx="8961120" cy="2377440"/>
           </a:xfrm>
+          <a:noFill/>
+          <a:ln>
+            <a:noFill/>
+          </a:ln>
         </p:spPr>
         <p:txBody>
-          <a:bodyPr/>
+          <a:bodyPr anchor="ctr" wrap="square" lIns="0" tIns="0" rIns="0" bIns="0"/>
           <a:lstStyle>
             <a:lvl1pPr>
-              <a:defRPr>
+              <a:defRPr sz="6000" b="1">
                 <a:solidFill>
-                  <a:srgbClr val="FFFFFF"/>
+                  <a:srgbClr val="111111"/>
                 </a:solidFill>
               </a:defRPr>
             </a:lvl1pPr>
           </a:lstStyle>
           <a:p>
+            <a:pPr algn="l"/>
             <a:r>
               <a:rPr lang="en-US" smtClean="0"/>
               <a:t>Click to edit Master title style</a:t>
@@ -177,18 +182,22 @@
         </p:nvSpPr>
         <p:spPr>
           <a:xfrm>
-            <a:off x="1371600" y="3886200"/>
-            <a:ext cx="6400800" cy="1752600"/>
+            <a:off x="502920" y="4206240"/>
+            <a:ext cx="7772400" cy="1463040"/>
           </a:xfrm>
+          <a:noFill/>
+          <a:ln>
+            <a:noFill/>
+          </a:ln>
         </p:spPr>
         <p:txBody>
-          <a:bodyPr/>
+          <a:bodyPr anchor="t" wrap="square" lIns="0" tIns="0" rIns="0" bIns="0"/>
           <a:lstStyle>
             <a:lvl1pPr marL="0" indent="0" algn="ctr">
               <a:buNone/>
-              <a:defRPr>
+              <a:defRPr sz="1800">
                 <a:solidFill>
-                  <a:srgbClr val="FFFFFF"/>
+                  <a:srgbClr val="444444"/>
                 </a:solidFill>
               </a:defRPr>
             </a:lvl1pPr>
@@ -274,6 +283,7 @@
             </a:lvl9pPr>
           </a:lstStyle>
           <a:p>
+            <a:pPr algn="l"/>
             <a:r>
               <a:rPr lang="en-US" smtClean="0"/>
               <a:t>Click to edit Master subtitle style</a:t>
@@ -363,6 +373,14 @@
 <file path=ppt/slideLayouts/slideLayout10.xml><?xml version="1.0" encoding="utf-8"?>
 <p:sldLayout xmlns:a="http://schemas.openxmlformats.org/drawingml/2006/main" xmlns:r="http://schemas.openxmlformats.org/officeDocument/2006/relationships" xmlns:p="http://schemas.openxmlformats.org/presentationml/2006/main" type="vertTx" preserve="1">
   <p:cSld name="Title and Vertical Text">
+    <p:bg>
+      <p:bgPr>
+        <a:solidFill>
+          <a:srgbClr val="FFFFFF"/>
+        </a:solidFill>
+        <a:effectLst/>
+      </p:bgPr>
+    </p:bg>
     <p:spTree>
       <p:nvGrpSpPr>
         <p:cNvPr id="1" name=""/>
@@ -533,6 +551,14 @@
 <file path=ppt/slideLayouts/slideLayout11.xml><?xml version="1.0" encoding="utf-8"?>
 <p:sldLayout xmlns:a="http://schemas.openxmlformats.org/drawingml/2006/main" xmlns:r="http://schemas.openxmlformats.org/officeDocument/2006/relationships" xmlns:p="http://schemas.openxmlformats.org/presentationml/2006/main" type="vertTitleAndTx" preserve="1">
   <p:cSld name="Vertical Title and Text">
+    <p:bg>
+      <p:bgPr>
+        <a:solidFill>
+          <a:srgbClr val="FFFFFF"/>
+        </a:solidFill>
+        <a:effectLst/>
+      </p:bgPr>
+    </p:bg>
     <p:spTree>
       <p:nvGrpSpPr>
         <p:cNvPr id="1" name=""/>
@@ -745,19 +771,29 @@
             <p:ph type="title"/>
           </p:nvPr>
         </p:nvSpPr>
-        <p:spPr/>
-        <p:txBody>
-          <a:bodyPr/>
+        <p:spPr>
+          <a:xfrm>
+            <a:off x="502920" y="365760"/>
+            <a:ext cx="10058400" cy="1508760"/>
+          </a:xfrm>
+          <a:noFill/>
+          <a:ln>
+            <a:noFill/>
+          </a:ln>
+        </p:spPr>
+        <p:txBody>
+          <a:bodyPr anchor="t" wrap="square" lIns="0" tIns="0" rIns="0" bIns="0"/>
           <a:lstStyle>
             <a:lvl1pPr>
-              <a:defRPr>
+              <a:defRPr sz="4800" b="1">
                 <a:solidFill>
-                  <a:srgbClr val="1A3A6C"/>
+                  <a:srgbClr val="111111"/>
                 </a:solidFill>
               </a:defRPr>
             </a:lvl1pPr>
           </a:lstStyle>
           <a:p>
+            <a:pPr algn="l"/>
             <a:r>
               <a:rPr lang="en-US" smtClean="0"/>
               <a:t>Click to edit Master title style</a:t>
@@ -776,20 +812,29 @@
             <p:ph idx="1"/>
           </p:nvPr>
         </p:nvSpPr>
-        <p:spPr/>
-        <p:txBody>
-          <a:bodyPr/>
+        <p:spPr>
+          <a:xfrm>
+            <a:off x="502920" y="2011680"/>
+            <a:ext cx="11247120" cy="4617720"/>
+          </a:xfrm>
+          <a:noFill/>
+          <a:ln>
+            <a:noFill/>
+          </a:ln>
+        </p:spPr>
+        <p:txBody>
+          <a:bodyPr anchor="t" wrap="square" lIns="0" tIns="36576" rIns="0" bIns="0"/>
           <a:lstStyle>
             <a:lvl1pPr>
-              <a:defRPr>
+              <a:defRPr sz="1600">
                 <a:solidFill>
-                  <a:srgbClr val="333333"/>
+                  <a:srgbClr val="444444"/>
                 </a:solidFill>
               </a:defRPr>
             </a:lvl1pPr>
           </a:lstStyle>
           <a:p>
-            <a:pPr lvl="0"/>
+            <a:pPr lvl="0" algn="l"/>
             <a:r>
               <a:rPr lang="en-US" smtClean="0"/>
               <a:t>Click to edit Master text styles</a:t>
@@ -910,7 +955,7 @@
     <p:bg>
       <p:bgPr>
         <a:solidFill>
-          <a:srgbClr val="1A3A6C"/>
+          <a:srgbClr val="FFFFFF"/>
         </a:solidFill>
         <a:effectLst/>
       </p:bgPr>
@@ -941,22 +986,27 @@
         </p:nvSpPr>
         <p:spPr>
           <a:xfrm>
-            <a:off x="722313" y="4406900"/>
-            <a:ext cx="7772400" cy="1362075"/>
+            <a:off x="502920" y="1828800"/>
+            <a:ext cx="9144000" cy="2103120"/>
           </a:xfrm>
+          <a:noFill/>
+          <a:ln>
+            <a:noFill/>
+          </a:ln>
         </p:spPr>
         <p:txBody>
-          <a:bodyPr anchor="t"/>
+          <a:bodyPr anchor="ctr" wrap="square" lIns="0" tIns="0" rIns="0" bIns="0"/>
           <a:lstStyle>
             <a:lvl1pPr algn="l">
-              <a:defRPr sz="4000" b="1" cap="all">
+              <a:defRPr sz="6000" b="1" cap="all">
                 <a:solidFill>
-                  <a:srgbClr val="FFFFFF"/>
+                  <a:srgbClr val="111111"/>
                 </a:solidFill>
               </a:defRPr>
             </a:lvl1pPr>
           </a:lstStyle>
           <a:p>
+            <a:pPr algn="l"/>
             <a:r>
               <a:rPr lang="en-US" smtClean="0"/>
               <a:t>Click to edit Master title style</a:t>
@@ -977,18 +1027,22 @@
         </p:nvSpPr>
         <p:spPr>
           <a:xfrm>
-            <a:off x="722313" y="2906713"/>
-            <a:ext cx="7772400" cy="1500187"/>
+            <a:off x="502920" y="4206240"/>
+            <a:ext cx="8229600" cy="1463040"/>
           </a:xfrm>
+          <a:noFill/>
+          <a:ln>
+            <a:noFill/>
+          </a:ln>
         </p:spPr>
         <p:txBody>
-          <a:bodyPr anchor="b"/>
+          <a:bodyPr anchor="t" wrap="square" lIns="0" tIns="0" rIns="0" bIns="0"/>
           <a:lstStyle>
             <a:lvl1pPr marL="0" indent="0">
               <a:buNone/>
-              <a:defRPr sz="2000">
+              <a:defRPr sz="1800">
                 <a:solidFill>
-                  <a:srgbClr val="FFFFFF"/>
+                  <a:srgbClr val="444444"/>
                 </a:solidFill>
               </a:defRPr>
             </a:lvl1pPr>
@@ -1074,7 +1128,7 @@
             </a:lvl9pPr>
           </a:lstStyle>
           <a:p>
-            <a:pPr lvl="0"/>
+            <a:pPr lvl="0" algn="l"/>
             <a:r>
               <a:rPr lang="en-US" smtClean="0"/>
               <a:t>Click to edit Master text styles</a:t>
@@ -1187,6 +1241,141 @@
       </p:grpSpPr>
       <p:sp>
         <p:nvSpPr>
+          <p:cNvPr id="11" name="Rounded Rectangle 11"/>
+          <p:cNvSpPr/>
+          <p:nvPr/>
+        </p:nvSpPr>
+        <p:spPr>
+          <a:xfrm>
+            <a:off x="8074152" y="1737360"/>
+            <a:ext cx="3692347" cy="4937760"/>
+          </a:xfrm>
+          <a:prstGeom prst="roundRect">
+            <a:avLst/>
+          </a:prstGeom>
+          <a:solidFill>
+            <a:srgbClr val="F2F2F2"/>
+          </a:solidFill>
+          <a:ln>
+            <a:solidFill>
+              <a:srgbClr val="CCCCCC"/>
+            </a:solidFill>
+          </a:ln>
+        </p:spPr>
+        <p:style>
+          <a:lnRef idx="1">
+            <a:schemeClr val="accent1"/>
+          </a:lnRef>
+          <a:fillRef idx="3">
+            <a:schemeClr val="accent1"/>
+          </a:fillRef>
+          <a:effectRef idx="2">
+            <a:schemeClr val="accent1"/>
+          </a:effectRef>
+          <a:fontRef idx="minor">
+            <a:schemeClr val="lt1"/>
+          </a:fontRef>
+        </p:style>
+        <p:txBody>
+          <a:bodyPr rtlCol="0" anchor="ctr"/>
+          <a:lstStyle/>
+          <a:p>
+            <a:pPr algn="ctr"/>
+          </a:p>
+        </p:txBody>
+      </p:sp>
+      <p:sp>
+        <p:nvSpPr>
+          <p:cNvPr id="10" name="Rounded Rectangle 10"/>
+          <p:cNvSpPr/>
+          <p:nvPr/>
+        </p:nvSpPr>
+        <p:spPr>
+          <a:xfrm>
+            <a:off x="4251960" y="1737360"/>
+            <a:ext cx="3692347" cy="4937760"/>
+          </a:xfrm>
+          <a:prstGeom prst="roundRect">
+            <a:avLst/>
+          </a:prstGeom>
+          <a:solidFill>
+            <a:srgbClr val="F2F2F2"/>
+          </a:solidFill>
+          <a:ln>
+            <a:solidFill>
+              <a:srgbClr val="CCCCCC"/>
+            </a:solidFill>
+          </a:ln>
+        </p:spPr>
+        <p:style>
+          <a:lnRef idx="1">
+            <a:schemeClr val="accent1"/>
+          </a:lnRef>
+          <a:fillRef idx="3">
+            <a:schemeClr val="accent1"/>
+          </a:fillRef>
+          <a:effectRef idx="2">
+            <a:schemeClr val="accent1"/>
+          </a:effectRef>
+          <a:fontRef idx="minor">
+            <a:schemeClr val="lt1"/>
+          </a:fontRef>
+        </p:style>
+        <p:txBody>
+          <a:bodyPr rtlCol="0" anchor="ctr"/>
+          <a:lstStyle/>
+          <a:p>
+            <a:pPr algn="ctr"/>
+          </a:p>
+        </p:txBody>
+      </p:sp>
+      <p:sp>
+        <p:nvSpPr>
+          <p:cNvPr id="9" name="Rounded Rectangle 9"/>
+          <p:cNvSpPr/>
+          <p:nvPr/>
+        </p:nvSpPr>
+        <p:spPr>
+          <a:xfrm>
+            <a:off x="429768" y="1737360"/>
+            <a:ext cx="3692347" cy="4937760"/>
+          </a:xfrm>
+          <a:prstGeom prst="roundRect">
+            <a:avLst/>
+          </a:prstGeom>
+          <a:solidFill>
+            <a:srgbClr val="F2F2F2"/>
+          </a:solidFill>
+          <a:ln>
+            <a:solidFill>
+              <a:srgbClr val="CCCCCC"/>
+            </a:solidFill>
+          </a:ln>
+        </p:spPr>
+        <p:style>
+          <a:lnRef idx="1">
+            <a:schemeClr val="accent1"/>
+          </a:lnRef>
+          <a:fillRef idx="3">
+            <a:schemeClr val="accent1"/>
+          </a:fillRef>
+          <a:effectRef idx="2">
+            <a:schemeClr val="accent1"/>
+          </a:effectRef>
+          <a:fontRef idx="minor">
+            <a:schemeClr val="lt1"/>
+          </a:fontRef>
+        </p:style>
+        <p:txBody>
+          <a:bodyPr rtlCol="0" anchor="ctr"/>
+          <a:lstStyle/>
+          <a:p>
+            <a:pPr algn="ctr"/>
+          </a:p>
+        </p:txBody>
+      </p:sp>
+      <p:sp>
+        <p:nvSpPr>
           <p:cNvPr id="2" name="Title 1"/>
           <p:cNvSpPr>
             <a:spLocks noGrp="1"/>
@@ -1195,19 +1384,29 @@
             <p:ph type="title"/>
           </p:nvPr>
         </p:nvSpPr>
-        <p:spPr/>
-        <p:txBody>
-          <a:bodyPr/>
+        <p:spPr>
+          <a:xfrm>
+            <a:off x="502920" y="320040"/>
+            <a:ext cx="10058400" cy="1325880"/>
+          </a:xfrm>
+          <a:noFill/>
+          <a:ln>
+            <a:noFill/>
+          </a:ln>
+        </p:spPr>
+        <p:txBody>
+          <a:bodyPr anchor="t" wrap="square" lIns="0" tIns="0" rIns="0" bIns="0"/>
           <a:lstStyle>
             <a:lvl1pPr>
-              <a:defRPr>
+              <a:defRPr sz="4800" b="1">
                 <a:solidFill>
-                  <a:srgbClr val="1A3A6C"/>
+                  <a:srgbClr val="111111"/>
                 </a:solidFill>
               </a:defRPr>
             </a:lvl1pPr>
           </a:lstStyle>
           <a:p>
+            <a:pPr algn="l"/>
             <a:r>
               <a:rPr lang="en-US" smtClean="0"/>
               <a:t>Click to edit Master title style</a:t>
@@ -1228,17 +1427,21 @@
         </p:nvSpPr>
         <p:spPr>
           <a:xfrm>
-            <a:off x="457200" y="1600200"/>
-            <a:ext cx="4038600" cy="4525963"/>
+            <a:off x="502920" y="1828800"/>
+            <a:ext cx="3546043" cy="4754880"/>
           </a:xfrm>
+          <a:noFill/>
+          <a:ln>
+            <a:noFill/>
+          </a:ln>
         </p:spPr>
         <p:txBody>
-          <a:bodyPr/>
+          <a:bodyPr anchor="t" wrap="square" lIns="73152" tIns="54864" rIns="73152" bIns="54864"/>
           <a:lstStyle>
             <a:lvl1pPr>
-              <a:defRPr sz="2800">
+              <a:defRPr sz="1400">
                 <a:solidFill>
-                  <a:srgbClr val="333333"/>
+                  <a:srgbClr val="444444"/>
                 </a:solidFill>
               </a:defRPr>
             </a:lvl1pPr>
@@ -1268,7 +1471,7 @@
             </a:lvl9pPr>
           </a:lstStyle>
           <a:p>
-            <a:pPr lvl="0"/>
+            <a:pPr lvl="0" algn="l"/>
             <a:r>
               <a:rPr lang="en-US" smtClean="0"/>
               <a:t>Click to edit Master text styles</a:t>
@@ -1317,17 +1520,21 @@
         </p:nvSpPr>
         <p:spPr>
           <a:xfrm>
-            <a:off x="4648200" y="1600200"/>
-            <a:ext cx="4038600" cy="4525963"/>
+            <a:off x="4325112" y="1828800"/>
+            <a:ext cx="3546043" cy="4754880"/>
           </a:xfrm>
+          <a:noFill/>
+          <a:ln>
+            <a:noFill/>
+          </a:ln>
         </p:spPr>
         <p:txBody>
-          <a:bodyPr/>
+          <a:bodyPr anchor="t" wrap="square" lIns="73152" tIns="54864" rIns="73152" bIns="54864"/>
           <a:lstStyle>
             <a:lvl1pPr>
-              <a:defRPr sz="2800">
+              <a:defRPr sz="1400">
                 <a:solidFill>
-                  <a:srgbClr val="333333"/>
+                  <a:srgbClr val="444444"/>
                 </a:solidFill>
               </a:defRPr>
             </a:lvl1pPr>
@@ -1357,7 +1564,7 @@
             </a:lvl9pPr>
           </a:lstStyle>
           <a:p>
-            <a:pPr lvl="0"/>
+            <a:pPr lvl="0" algn="l"/>
             <a:r>
               <a:rPr lang="en-US" smtClean="0"/>
               <a:t>Click to edit Master text styles</a:t>
@@ -1456,6 +1663,45 @@
               <a:t>‹#›</a:t>
             </a:fld>
             <a:endParaRPr lang="en-US"/>
+          </a:p>
+        </p:txBody>
+      </p:sp>
+      <p:sp>
+        <p:nvSpPr>
+          <p:cNvPr id="8" name="Content Placeholder 3"/>
+          <p:cNvSpPr>
+            <a:spLocks noGrp="1"/>
+          </p:cNvSpPr>
+          <p:nvPr>
+            <p:ph idx="3"/>
+          </p:nvPr>
+        </p:nvSpPr>
+        <p:spPr>
+          <a:xfrm>
+            <a:off x="8147304" y="1828800"/>
+            <a:ext cx="3546043" cy="4754880"/>
+          </a:xfrm>
+          <a:prstGeom prst="rect">
+            <a:avLst/>
+          </a:prstGeom>
+          <a:noFill/>
+          <a:ln>
+            <a:noFill/>
+          </a:ln>
+        </p:spPr>
+        <p:txBody>
+          <a:bodyPr anchor="t" wrap="square" lIns="73152" tIns="54864" rIns="73152" bIns="54864"/>
+          <a:lstStyle>
+            <a:lvl1pPr>
+              <a:defRPr sz="1400">
+                <a:solidFill>
+                  <a:srgbClr val="444444"/>
+                </a:solidFill>
+              </a:defRPr>
+            </a:lvl1pPr>
+          </a:lstStyle>
+          <a:p>
+            <a:pPr algn="l"/>
           </a:p>
         </p:txBody>
       </p:sp>
@@ -1499,6 +1745,96 @@
       </p:grpSpPr>
       <p:sp>
         <p:nvSpPr>
+          <p:cNvPr id="11" name="Rounded Rectangle 11"/>
+          <p:cNvSpPr/>
+          <p:nvPr/>
+        </p:nvSpPr>
+        <p:spPr>
+          <a:xfrm>
+            <a:off x="6245352" y="1874519"/>
+            <a:ext cx="5440680" cy="4709160"/>
+          </a:xfrm>
+          <a:prstGeom prst="roundRect">
+            <a:avLst/>
+          </a:prstGeom>
+          <a:solidFill>
+            <a:srgbClr val="F2F2F2"/>
+          </a:solidFill>
+          <a:ln>
+            <a:solidFill>
+              <a:srgbClr val="CCCCCC"/>
+            </a:solidFill>
+          </a:ln>
+        </p:spPr>
+        <p:style>
+          <a:lnRef idx="1">
+            <a:schemeClr val="accent1"/>
+          </a:lnRef>
+          <a:fillRef idx="3">
+            <a:schemeClr val="accent1"/>
+          </a:fillRef>
+          <a:effectRef idx="2">
+            <a:schemeClr val="accent1"/>
+          </a:effectRef>
+          <a:fontRef idx="minor">
+            <a:schemeClr val="lt1"/>
+          </a:fontRef>
+        </p:style>
+        <p:txBody>
+          <a:bodyPr rtlCol="0" anchor="ctr"/>
+          <a:lstStyle/>
+          <a:p>
+            <a:pPr algn="ctr"/>
+          </a:p>
+        </p:txBody>
+      </p:sp>
+      <p:sp>
+        <p:nvSpPr>
+          <p:cNvPr id="10" name="Rounded Rectangle 10"/>
+          <p:cNvSpPr/>
+          <p:nvPr/>
+        </p:nvSpPr>
+        <p:spPr>
+          <a:xfrm>
+            <a:off x="502920" y="1874519"/>
+            <a:ext cx="5440680" cy="4709160"/>
+          </a:xfrm>
+          <a:prstGeom prst="roundRect">
+            <a:avLst/>
+          </a:prstGeom>
+          <a:solidFill>
+            <a:srgbClr val="F2F2F2"/>
+          </a:solidFill>
+          <a:ln>
+            <a:solidFill>
+              <a:srgbClr val="CCCCCC"/>
+            </a:solidFill>
+          </a:ln>
+        </p:spPr>
+        <p:style>
+          <a:lnRef idx="1">
+            <a:schemeClr val="accent1"/>
+          </a:lnRef>
+          <a:fillRef idx="3">
+            <a:schemeClr val="accent1"/>
+          </a:fillRef>
+          <a:effectRef idx="2">
+            <a:schemeClr val="accent1"/>
+          </a:effectRef>
+          <a:fontRef idx="minor">
+            <a:schemeClr val="lt1"/>
+          </a:fontRef>
+        </p:style>
+        <p:txBody>
+          <a:bodyPr rtlCol="0" anchor="ctr"/>
+          <a:lstStyle/>
+          <a:p>
+            <a:pPr algn="ctr"/>
+          </a:p>
+        </p:txBody>
+      </p:sp>
+      <p:sp>
+        <p:nvSpPr>
           <p:cNvPr id="2" name="Title 1"/>
           <p:cNvSpPr>
             <a:spLocks noGrp="1"/>
@@ -1507,19 +1843,29 @@
             <p:ph type="title"/>
           </p:nvPr>
         </p:nvSpPr>
-        <p:spPr/>
-        <p:txBody>
-          <a:bodyPr/>
+        <p:spPr>
+          <a:xfrm>
+            <a:off x="502920" y="320040"/>
+            <a:ext cx="10058400" cy="1417320"/>
+          </a:xfrm>
+          <a:noFill/>
+          <a:ln>
+            <a:noFill/>
+          </a:ln>
+        </p:spPr>
+        <p:txBody>
+          <a:bodyPr anchor="t" wrap="square" lIns="0" tIns="0" rIns="0" bIns="0"/>
           <a:lstStyle>
             <a:lvl1pPr>
-              <a:defRPr>
+              <a:defRPr sz="5400" b="1">
                 <a:solidFill>
-                  <a:srgbClr val="1A3A6C"/>
+                  <a:srgbClr val="111111"/>
                 </a:solidFill>
               </a:defRPr>
             </a:lvl1pPr>
           </a:lstStyle>
           <a:p>
+            <a:pPr algn="l"/>
             <a:r>
               <a:rPr lang="en-US" smtClean="0"/>
               <a:t>Click to edit Master title style</a:t>
@@ -1540,18 +1886,22 @@
         </p:nvSpPr>
         <p:spPr>
           <a:xfrm>
-            <a:off x="457200" y="1535113"/>
-            <a:ext cx="4040188" cy="639762"/>
+            <a:off x="804672" y="2057400"/>
+            <a:ext cx="4846320" cy="502920"/>
           </a:xfrm>
+          <a:noFill/>
+          <a:ln>
+            <a:noFill/>
+          </a:ln>
         </p:spPr>
         <p:txBody>
-          <a:bodyPr anchor="b"/>
+          <a:bodyPr anchor="t" wrap="square" lIns="73152" tIns="36576" rIns="73152" bIns="0"/>
           <a:lstStyle>
             <a:lvl1pPr marL="0" indent="0">
               <a:buNone/>
-              <a:defRPr sz="2400" b="1">
+              <a:defRPr sz="1400" b="1">
                 <a:solidFill>
-                  <a:srgbClr val="333333"/>
+                  <a:srgbClr val="111111"/>
                 </a:solidFill>
               </a:defRPr>
             </a:lvl1pPr>
@@ -1589,7 +1939,7 @@
             </a:lvl9pPr>
           </a:lstStyle>
           <a:p>
-            <a:pPr lvl="0"/>
+            <a:pPr lvl="0" algn="l"/>
             <a:r>
               <a:rPr lang="en-US" smtClean="0"/>
               <a:t>Click to edit Master text styles</a:t>
@@ -1609,17 +1959,21 @@
         </p:nvSpPr>
         <p:spPr>
           <a:xfrm>
-            <a:off x="457200" y="2174875"/>
-            <a:ext cx="4040188" cy="3951288"/>
+            <a:off x="804672" y="2651760"/>
+            <a:ext cx="4846320" cy="3749039"/>
           </a:xfrm>
+          <a:noFill/>
+          <a:ln>
+            <a:noFill/>
+          </a:ln>
         </p:spPr>
         <p:txBody>
-          <a:bodyPr/>
+          <a:bodyPr anchor="t" wrap="square" lIns="73152" tIns="36576" rIns="73152" bIns="36576"/>
           <a:lstStyle>
             <a:lvl1pPr>
-              <a:defRPr sz="2400">
+              <a:defRPr sz="1400">
                 <a:solidFill>
-                  <a:srgbClr val="333333"/>
+                  <a:srgbClr val="444444"/>
                 </a:solidFill>
               </a:defRPr>
             </a:lvl1pPr>
@@ -1649,7 +2003,7 @@
             </a:lvl9pPr>
           </a:lstStyle>
           <a:p>
-            <a:pPr lvl="0"/>
+            <a:pPr lvl="0" algn="l"/>
             <a:r>
               <a:rPr lang="en-US" smtClean="0"/>
               <a:t>Click to edit Master text styles</a:t>
@@ -1698,18 +2052,22 @@
         </p:nvSpPr>
         <p:spPr>
           <a:xfrm>
-            <a:off x="4645025" y="1535113"/>
-            <a:ext cx="4041775" cy="639762"/>
+            <a:off x="6547104" y="2057400"/>
+            <a:ext cx="4846320" cy="502920"/>
           </a:xfrm>
+          <a:noFill/>
+          <a:ln>
+            <a:noFill/>
+          </a:ln>
         </p:spPr>
         <p:txBody>
-          <a:bodyPr anchor="b"/>
+          <a:bodyPr anchor="t" wrap="square" lIns="73152" tIns="36576" rIns="73152" bIns="0"/>
           <a:lstStyle>
             <a:lvl1pPr marL="0" indent="0">
               <a:buNone/>
-              <a:defRPr sz="2400" b="1">
+              <a:defRPr sz="1400" b="1">
                 <a:solidFill>
-                  <a:srgbClr val="333333"/>
+                  <a:srgbClr val="111111"/>
                 </a:solidFill>
               </a:defRPr>
             </a:lvl1pPr>
@@ -1747,7 +2105,7 @@
             </a:lvl9pPr>
           </a:lstStyle>
           <a:p>
-            <a:pPr lvl="0"/>
+            <a:pPr lvl="0" algn="l"/>
             <a:r>
               <a:rPr lang="en-US" smtClean="0"/>
               <a:t>Click to edit Master text styles</a:t>
@@ -1767,17 +2125,21 @@
         </p:nvSpPr>
         <p:spPr>
           <a:xfrm>
-            <a:off x="4645025" y="2174875"/>
-            <a:ext cx="4041775" cy="3951288"/>
+            <a:off x="6547104" y="2651760"/>
+            <a:ext cx="4846320" cy="3749039"/>
           </a:xfrm>
+          <a:noFill/>
+          <a:ln>
+            <a:noFill/>
+          </a:ln>
         </p:spPr>
         <p:txBody>
-          <a:bodyPr/>
+          <a:bodyPr anchor="t" wrap="square" lIns="73152" tIns="36576" rIns="73152" bIns="36576"/>
           <a:lstStyle>
             <a:lvl1pPr>
-              <a:defRPr sz="2400">
+              <a:defRPr sz="1400">
                 <a:solidFill>
-                  <a:srgbClr val="333333"/>
+                  <a:srgbClr val="444444"/>
                 </a:solidFill>
               </a:defRPr>
             </a:lvl1pPr>
@@ -1807,7 +2169,7 @@
             </a:lvl9pPr>
           </a:lstStyle>
           <a:p>
-            <a:pPr lvl="0"/>
+            <a:pPr lvl="0" algn="l"/>
             <a:r>
               <a:rPr lang="en-US" smtClean="0"/>
               <a:t>Click to edit Master text styles</a:t>
@@ -1925,6 +2287,14 @@
 <file path=ppt/slideLayouts/slideLayout6.xml><?xml version="1.0" encoding="utf-8"?>
 <p:sldLayout xmlns:a="http://schemas.openxmlformats.org/drawingml/2006/main" xmlns:r="http://schemas.openxmlformats.org/officeDocument/2006/relationships" xmlns:p="http://schemas.openxmlformats.org/presentationml/2006/main" type="titleOnly" preserve="1">
   <p:cSld name="Title Only">
+    <p:bg>
+      <p:bgPr>
+        <a:solidFill>
+          <a:srgbClr val="FFFFFF"/>
+        </a:solidFill>
+        <a:effectLst/>
+      </p:bgPr>
+    </p:bg>
     <p:spTree>
       <p:nvGrpSpPr>
         <p:cNvPr id="1" name=""/>
@@ -2043,6 +2413,14 @@
 <file path=ppt/slideLayouts/slideLayout7.xml><?xml version="1.0" encoding="utf-8"?>
 <p:sldLayout xmlns:a="http://schemas.openxmlformats.org/drawingml/2006/main" xmlns:r="http://schemas.openxmlformats.org/officeDocument/2006/relationships" xmlns:p="http://schemas.openxmlformats.org/presentationml/2006/main" type="blank" preserve="1">
   <p:cSld name="Blank">
+    <p:bg>
+      <p:bgPr>
+        <a:solidFill>
+          <a:srgbClr val="FFFFFF"/>
+        </a:solidFill>
+        <a:effectLst/>
+      </p:bgPr>
+    </p:bg>
     <p:spTree>
       <p:nvGrpSpPr>
         <p:cNvPr id="1" name=""/>
@@ -2138,6 +2516,14 @@
 <file path=ppt/slideLayouts/slideLayout8.xml><?xml version="1.0" encoding="utf-8"?>
 <p:sldLayout xmlns:a="http://schemas.openxmlformats.org/drawingml/2006/main" xmlns:r="http://schemas.openxmlformats.org/officeDocument/2006/relationships" xmlns:p="http://schemas.openxmlformats.org/presentationml/2006/main" type="objTx" preserve="1">
   <p:cSld name="Content with Caption">
+    <p:bg>
+      <p:bgPr>
+        <a:solidFill>
+          <a:srgbClr val="FFFFFF"/>
+        </a:solidFill>
+        <a:effectLst/>
+      </p:bgPr>
+    </p:bg>
     <p:spTree>
       <p:nvGrpSpPr>
         <p:cNvPr id="1" name=""/>
@@ -2449,22 +2835,27 @@
         </p:nvSpPr>
         <p:spPr>
           <a:xfrm>
-            <a:off x="1792288" y="4800600"/>
-            <a:ext cx="5486400" cy="566738"/>
+            <a:off x="502920" y="320040"/>
+            <a:ext cx="10058400" cy="1417320"/>
           </a:xfrm>
+          <a:noFill/>
+          <a:ln>
+            <a:noFill/>
+          </a:ln>
         </p:spPr>
         <p:txBody>
-          <a:bodyPr anchor="b"/>
+          <a:bodyPr anchor="t" wrap="square" lIns="0" tIns="0" rIns="0" bIns="0"/>
           <a:lstStyle>
             <a:lvl1pPr algn="l">
-              <a:defRPr sz="2000" b="1">
+              <a:defRPr sz="5400" b="1">
                 <a:solidFill>
-                  <a:srgbClr val="1A3A6C"/>
+                  <a:srgbClr val="111111"/>
                 </a:solidFill>
               </a:defRPr>
             </a:lvl1pPr>
           </a:lstStyle>
           <a:p>
+            <a:pPr algn="l"/>
             <a:r>
               <a:rPr lang="en-US" smtClean="0"/>
               <a:t>Click to edit Master title style</a:t>
@@ -2485,12 +2876,20 @@
         </p:nvSpPr>
         <p:spPr>
           <a:xfrm>
-            <a:off x="1792288" y="612775"/>
-            <a:ext cx="5486400" cy="4114800"/>
+            <a:off x="502920" y="1920240"/>
+            <a:ext cx="7772400" cy="4663440"/>
           </a:xfrm>
+          <a:solidFill>
+            <a:srgbClr val="F2F2F2"/>
+          </a:solidFill>
+          <a:ln>
+            <a:solidFill>
+              <a:srgbClr val="CCCCCC"/>
+            </a:solidFill>
+          </a:ln>
         </p:spPr>
         <p:txBody>
-          <a:bodyPr/>
+          <a:bodyPr anchor="t" wrap="square" lIns="0" tIns="0" rIns="0" bIns="0"/>
           <a:lstStyle>
             <a:lvl1pPr marL="0" indent="0">
               <a:buNone/>
@@ -2530,6 +2929,7 @@
             </a:lvl9pPr>
           </a:lstStyle>
           <a:p>
+            <a:pPr algn="l"/>
             <a:endParaRPr lang="en-US"/>
           </a:p>
         </p:txBody>
@@ -2546,18 +2946,22 @@
         </p:nvSpPr>
         <p:spPr>
           <a:xfrm>
-            <a:off x="1792288" y="5367338"/>
-            <a:ext cx="5486400" cy="804862"/>
+            <a:off x="8531352" y="1920240"/>
+            <a:ext cx="3154680" cy="4663440"/>
           </a:xfrm>
+          <a:noFill/>
+          <a:ln>
+            <a:noFill/>
+          </a:ln>
         </p:spPr>
         <p:txBody>
-          <a:bodyPr/>
+          <a:bodyPr anchor="t" wrap="square" lIns="0" tIns="36576" rIns="0" bIns="0"/>
           <a:lstStyle>
             <a:lvl1pPr marL="0" indent="0">
               <a:buNone/>
               <a:defRPr sz="1400">
                 <a:solidFill>
-                  <a:srgbClr val="333333"/>
+                  <a:srgbClr val="444444"/>
                 </a:solidFill>
               </a:defRPr>
             </a:lvl1pPr>
@@ -2595,7 +2999,7 @@
             </a:lvl9pPr>
           </a:lstStyle>
           <a:p>
-            <a:pPr lvl="0"/>
+            <a:pPr lvl="0" algn="l"/>
             <a:r>
               <a:rPr lang="en-US" smtClean="0"/>
               <a:t>Click to edit Master text styles</a:t>
@@ -2706,6 +3110,264 @@
           <a:chExt cx="0" cy="0"/>
         </a:xfrm>
       </p:grpSpPr>
+      <p:sp>
+        <p:nvSpPr>
+          <p:cNvPr id="2147483665" name="Oval 2147483665"/>
+          <p:cNvSpPr/>
+          <p:nvPr/>
+        </p:nvSpPr>
+        <p:spPr>
+          <a:xfrm>
+            <a:off x="3505198" y="-8686800"/>
+            <a:ext cx="17373600" cy="17373600"/>
+          </a:xfrm>
+          <a:prstGeom prst="ellipse">
+            <a:avLst/>
+          </a:prstGeom>
+          <a:noFill/>
+          <a:ln w="6350">
+            <a:solidFill>
+              <a:srgbClr val="E7E7E7"/>
+            </a:solidFill>
+          </a:ln>
+        </p:spPr>
+        <p:style>
+          <a:lnRef idx="1">
+            <a:schemeClr val="accent1"/>
+          </a:lnRef>
+          <a:fillRef idx="3">
+            <a:schemeClr val="accent1"/>
+          </a:fillRef>
+          <a:effectRef idx="2">
+            <a:schemeClr val="accent1"/>
+          </a:effectRef>
+          <a:fontRef idx="minor">
+            <a:schemeClr val="lt1"/>
+          </a:fontRef>
+        </p:style>
+        <p:txBody>
+          <a:bodyPr rtlCol="0" anchor="ctr"/>
+          <a:lstStyle/>
+          <a:p>
+            <a:pPr algn="ctr"/>
+          </a:p>
+        </p:txBody>
+      </p:sp>
+      <p:sp>
+        <p:nvSpPr>
+          <p:cNvPr id="2147483664" name="Oval 2147483664"/>
+          <p:cNvSpPr/>
+          <p:nvPr/>
+        </p:nvSpPr>
+        <p:spPr>
+          <a:xfrm>
+            <a:off x="4145278" y="-8046720"/>
+            <a:ext cx="16093440" cy="16093440"/>
+          </a:xfrm>
+          <a:prstGeom prst="ellipse">
+            <a:avLst/>
+          </a:prstGeom>
+          <a:noFill/>
+          <a:ln w="9525">
+            <a:solidFill>
+              <a:srgbClr val="DFDFDF"/>
+            </a:solidFill>
+          </a:ln>
+        </p:spPr>
+        <p:style>
+          <a:lnRef idx="1">
+            <a:schemeClr val="accent1"/>
+          </a:lnRef>
+          <a:fillRef idx="3">
+            <a:schemeClr val="accent1"/>
+          </a:fillRef>
+          <a:effectRef idx="2">
+            <a:schemeClr val="accent1"/>
+          </a:effectRef>
+          <a:fontRef idx="minor">
+            <a:schemeClr val="lt1"/>
+          </a:fontRef>
+        </p:style>
+        <p:txBody>
+          <a:bodyPr rtlCol="0" anchor="ctr"/>
+          <a:lstStyle/>
+          <a:p>
+            <a:pPr algn="ctr"/>
+          </a:p>
+        </p:txBody>
+      </p:sp>
+      <p:sp>
+        <p:nvSpPr>
+          <p:cNvPr id="2147483663" name="Oval 2147483663"/>
+          <p:cNvSpPr/>
+          <p:nvPr/>
+        </p:nvSpPr>
+        <p:spPr>
+          <a:xfrm>
+            <a:off x="5242559" y="-6949440"/>
+            <a:ext cx="13898880" cy="13898880"/>
+          </a:xfrm>
+          <a:prstGeom prst="ellipse">
+            <a:avLst/>
+          </a:prstGeom>
+          <a:noFill/>
+          <a:ln w="9525">
+            <a:solidFill>
+              <a:srgbClr val="D7D7D7"/>
+            </a:solidFill>
+          </a:ln>
+        </p:spPr>
+        <p:style>
+          <a:lnRef idx="1">
+            <a:schemeClr val="accent1"/>
+          </a:lnRef>
+          <a:fillRef idx="3">
+            <a:schemeClr val="accent1"/>
+          </a:fillRef>
+          <a:effectRef idx="2">
+            <a:schemeClr val="accent1"/>
+          </a:effectRef>
+          <a:fontRef idx="minor">
+            <a:schemeClr val="lt1"/>
+          </a:fontRef>
+        </p:style>
+        <p:txBody>
+          <a:bodyPr rtlCol="0" anchor="ctr"/>
+          <a:lstStyle/>
+          <a:p>
+            <a:pPr algn="ctr"/>
+          </a:p>
+        </p:txBody>
+      </p:sp>
+      <p:sp>
+        <p:nvSpPr>
+          <p:cNvPr id="2147483662" name="Oval 2147483662"/>
+          <p:cNvSpPr/>
+          <p:nvPr/>
+        </p:nvSpPr>
+        <p:spPr>
+          <a:xfrm>
+            <a:off x="6339838" y="-5852160"/>
+            <a:ext cx="11704320" cy="11704320"/>
+          </a:xfrm>
+          <a:prstGeom prst="ellipse">
+            <a:avLst/>
+          </a:prstGeom>
+          <a:noFill/>
+          <a:ln w="12700">
+            <a:solidFill>
+              <a:srgbClr val="CECECE"/>
+            </a:solidFill>
+          </a:ln>
+        </p:spPr>
+        <p:style>
+          <a:lnRef idx="1">
+            <a:schemeClr val="accent1"/>
+          </a:lnRef>
+          <a:fillRef idx="3">
+            <a:schemeClr val="accent1"/>
+          </a:fillRef>
+          <a:effectRef idx="2">
+            <a:schemeClr val="accent1"/>
+          </a:effectRef>
+          <a:fontRef idx="minor">
+            <a:schemeClr val="lt1"/>
+          </a:fontRef>
+        </p:style>
+        <p:txBody>
+          <a:bodyPr rtlCol="0" anchor="ctr"/>
+          <a:lstStyle/>
+          <a:p>
+            <a:pPr algn="ctr"/>
+          </a:p>
+        </p:txBody>
+      </p:sp>
+      <p:sp>
+        <p:nvSpPr>
+          <p:cNvPr id="2147483661" name="Oval 2147483661"/>
+          <p:cNvSpPr/>
+          <p:nvPr/>
+        </p:nvSpPr>
+        <p:spPr>
+          <a:xfrm>
+            <a:off x="7437118" y="-4754880"/>
+            <a:ext cx="9509760" cy="9509760"/>
+          </a:xfrm>
+          <a:prstGeom prst="ellipse">
+            <a:avLst/>
+          </a:prstGeom>
+          <a:noFill/>
+          <a:ln w="15875">
+            <a:solidFill>
+              <a:srgbClr val="C5C5C5"/>
+            </a:solidFill>
+          </a:ln>
+        </p:spPr>
+        <p:style>
+          <a:lnRef idx="1">
+            <a:schemeClr val="accent1"/>
+          </a:lnRef>
+          <a:fillRef idx="3">
+            <a:schemeClr val="accent1"/>
+          </a:fillRef>
+          <a:effectRef idx="2">
+            <a:schemeClr val="accent1"/>
+          </a:effectRef>
+          <a:fontRef idx="minor">
+            <a:schemeClr val="lt1"/>
+          </a:fontRef>
+        </p:style>
+        <p:txBody>
+          <a:bodyPr rtlCol="0" anchor="ctr"/>
+          <a:lstStyle/>
+          <a:p>
+            <a:pPr algn="ctr"/>
+          </a:p>
+        </p:txBody>
+      </p:sp>
+      <p:sp>
+        <p:nvSpPr>
+          <p:cNvPr id="2147483660" name="Oval 2147483660"/>
+          <p:cNvSpPr/>
+          <p:nvPr/>
+        </p:nvSpPr>
+        <p:spPr>
+          <a:xfrm>
+            <a:off x="8534399" y="-3657600"/>
+            <a:ext cx="7315200" cy="7315200"/>
+          </a:xfrm>
+          <a:prstGeom prst="ellipse">
+            <a:avLst/>
+          </a:prstGeom>
+          <a:noFill/>
+          <a:ln w="19050">
+            <a:solidFill>
+              <a:srgbClr val="BBBBBB"/>
+            </a:solidFill>
+          </a:ln>
+        </p:spPr>
+        <p:style>
+          <a:lnRef idx="1">
+            <a:schemeClr val="accent1"/>
+          </a:lnRef>
+          <a:fillRef idx="3">
+            <a:schemeClr val="accent1"/>
+          </a:fillRef>
+          <a:effectRef idx="2">
+            <a:schemeClr val="accent1"/>
+          </a:effectRef>
+          <a:fontRef idx="minor">
+            <a:schemeClr val="lt1"/>
+          </a:fontRef>
+        </p:style>
+        <p:txBody>
+          <a:bodyPr rtlCol="0" anchor="ctr"/>
+          <a:lstStyle/>
+          <a:p>
+            <a:pPr algn="ctr"/>
+          </a:p>
+        </p:txBody>
+      </p:sp>
       <p:sp>
         <p:nvSpPr>
           <p:cNvPr id="2" name="Title Placeholder 1"/>

</xml_diff>